<commit_message>
poster now with emojis
</commit_message>
<xml_diff>
--- a/Poster.pptx
+++ b/Poster.pptx
@@ -12152,7 +12152,7 @@
         </p:nvSpPr>
         <p:spPr>
           <a:xfrm>
-            <a:off x="14075773" y="10448093"/>
+            <a:off x="14075773" y="10328825"/>
             <a:ext cx="6728759" cy="646331"/>
           </a:xfrm>
           <a:prstGeom prst="rect">
@@ -12192,454 +12192,6 @@
           </a:p>
         </p:txBody>
       </p:sp>
-      <p:grpSp>
-        <p:nvGrpSpPr>
-          <p:cNvPr id="180" name="Gruppieren 179">
-            <a:extLst>
-              <a:ext uri="{FF2B5EF4-FFF2-40B4-BE49-F238E27FC236}">
-                <a16:creationId xmlns:a16="http://schemas.microsoft.com/office/drawing/2014/main" id="{8E59BD49-C444-2D09-D120-BCF7D03A063C}"/>
-              </a:ext>
-            </a:extLst>
-          </p:cNvPr>
-          <p:cNvGrpSpPr/>
-          <p:nvPr/>
-        </p:nvGrpSpPr>
-        <p:grpSpPr>
-          <a:xfrm>
-            <a:off x="13882912" y="6446298"/>
-            <a:ext cx="6961368" cy="3948762"/>
-            <a:chOff x="13882912" y="6358616"/>
-            <a:chExt cx="6961368" cy="3948762"/>
-          </a:xfrm>
-        </p:grpSpPr>
-        <p:pic>
-          <p:nvPicPr>
-            <p:cNvPr id="133" name="Grafik 132">
-              <a:extLst>
-                <a:ext uri="{FF2B5EF4-FFF2-40B4-BE49-F238E27FC236}">
-                  <a16:creationId xmlns:a16="http://schemas.microsoft.com/office/drawing/2014/main" id="{20D9CACF-30E4-CA18-16B8-813D81AE98DB}"/>
-                </a:ext>
-              </a:extLst>
-            </p:cNvPr>
-            <p:cNvPicPr>
-              <a:picLocks noChangeAspect="1"/>
-            </p:cNvPicPr>
-            <p:nvPr/>
-          </p:nvPicPr>
-          <p:blipFill>
-            <a:blip r:embed="rId10"/>
-            <a:srcRect b="6290"/>
-            <a:stretch>
-              <a:fillRect/>
-            </a:stretch>
-          </p:blipFill>
-          <p:spPr>
-            <a:xfrm>
-              <a:off x="14102136" y="6358616"/>
-              <a:ext cx="6742144" cy="3948762"/>
-            </a:xfrm>
-            <a:prstGeom prst="rect">
-              <a:avLst/>
-            </a:prstGeom>
-          </p:spPr>
-        </p:pic>
-        <p:sp>
-          <p:nvSpPr>
-            <p:cNvPr id="144" name="Textfeld 143">
-              <a:extLst>
-                <a:ext uri="{FF2B5EF4-FFF2-40B4-BE49-F238E27FC236}">
-                  <a16:creationId xmlns:a16="http://schemas.microsoft.com/office/drawing/2014/main" id="{79A73576-F283-8CC4-94E4-EBA0F884D060}"/>
-                </a:ext>
-              </a:extLst>
-            </p:cNvPr>
-            <p:cNvSpPr txBox="1"/>
-            <p:nvPr/>
-          </p:nvSpPr>
-          <p:spPr>
-            <a:xfrm>
-              <a:off x="13882912" y="7046684"/>
-              <a:ext cx="407907" cy="338554"/>
-            </a:xfrm>
-            <a:prstGeom prst="rect">
-              <a:avLst/>
-            </a:prstGeom>
-            <a:noFill/>
-          </p:spPr>
-          <p:txBody>
-            <a:bodyPr wrap="square" rtlCol="0">
-              <a:spAutoFit/>
-            </a:bodyPr>
-            <a:lstStyle/>
-            <a:p>
-              <a:r>
-                <a:rPr lang="de-DE" sz="1600" dirty="0"/>
-                <a:t>🇦🇹</a:t>
-              </a:r>
-              <a:endParaRPr lang="de-DE" sz="1050" dirty="0"/>
-            </a:p>
-          </p:txBody>
-        </p:sp>
-        <p:sp>
-          <p:nvSpPr>
-            <p:cNvPr id="145" name="Textfeld 144">
-              <a:extLst>
-                <a:ext uri="{FF2B5EF4-FFF2-40B4-BE49-F238E27FC236}">
-                  <a16:creationId xmlns:a16="http://schemas.microsoft.com/office/drawing/2014/main" id="{8B86430E-263E-7649-2475-BE5B845CC1D2}"/>
-                </a:ext>
-              </a:extLst>
-            </p:cNvPr>
-            <p:cNvSpPr txBox="1"/>
-            <p:nvPr/>
-          </p:nvSpPr>
-          <p:spPr>
-            <a:xfrm>
-              <a:off x="13882915" y="7322453"/>
-              <a:ext cx="407907" cy="338554"/>
-            </a:xfrm>
-            <a:prstGeom prst="rect">
-              <a:avLst/>
-            </a:prstGeom>
-            <a:noFill/>
-          </p:spPr>
-          <p:txBody>
-            <a:bodyPr wrap="square" rtlCol="0">
-              <a:spAutoFit/>
-            </a:bodyPr>
-            <a:lstStyle/>
-            <a:p>
-              <a:r>
-                <a:rPr lang="de-DE" sz="1600" dirty="0"/>
-                <a:t>🇧🇪</a:t>
-              </a:r>
-              <a:endParaRPr lang="de-DE" sz="1050" dirty="0"/>
-            </a:p>
-          </p:txBody>
-        </p:sp>
-        <p:sp>
-          <p:nvSpPr>
-            <p:cNvPr id="146" name="Textfeld 145">
-              <a:extLst>
-                <a:ext uri="{FF2B5EF4-FFF2-40B4-BE49-F238E27FC236}">
-                  <a16:creationId xmlns:a16="http://schemas.microsoft.com/office/drawing/2014/main" id="{38755C79-3FE7-C15B-8A00-B4AED9854FBB}"/>
-                </a:ext>
-              </a:extLst>
-            </p:cNvPr>
-            <p:cNvSpPr txBox="1"/>
-            <p:nvPr/>
-          </p:nvSpPr>
-          <p:spPr>
-            <a:xfrm>
-              <a:off x="13882915" y="7619995"/>
-              <a:ext cx="407907" cy="338554"/>
-            </a:xfrm>
-            <a:prstGeom prst="rect">
-              <a:avLst/>
-            </a:prstGeom>
-            <a:noFill/>
-          </p:spPr>
-          <p:txBody>
-            <a:bodyPr wrap="square" rtlCol="0">
-              <a:spAutoFit/>
-            </a:bodyPr>
-            <a:lstStyle/>
-            <a:p>
-              <a:r>
-                <a:rPr lang="de-DE" sz="1600" dirty="0"/>
-                <a:t>🇫🇮</a:t>
-              </a:r>
-              <a:endParaRPr lang="de-DE" sz="1050" dirty="0"/>
-            </a:p>
-          </p:txBody>
-        </p:sp>
-        <p:sp>
-          <p:nvSpPr>
-            <p:cNvPr id="147" name="Textfeld 146">
-              <a:extLst>
-                <a:ext uri="{FF2B5EF4-FFF2-40B4-BE49-F238E27FC236}">
-                  <a16:creationId xmlns:a16="http://schemas.microsoft.com/office/drawing/2014/main" id="{8B0424FB-7519-4627-69BE-CA71EACF15D0}"/>
-                </a:ext>
-              </a:extLst>
-            </p:cNvPr>
-            <p:cNvSpPr txBox="1"/>
-            <p:nvPr/>
-          </p:nvSpPr>
-          <p:spPr>
-            <a:xfrm>
-              <a:off x="13882915" y="7888510"/>
-              <a:ext cx="407907" cy="338554"/>
-            </a:xfrm>
-            <a:prstGeom prst="rect">
-              <a:avLst/>
-            </a:prstGeom>
-            <a:noFill/>
-          </p:spPr>
-          <p:txBody>
-            <a:bodyPr wrap="square" rtlCol="0">
-              <a:spAutoFit/>
-            </a:bodyPr>
-            <a:lstStyle/>
-            <a:p>
-              <a:r>
-                <a:rPr lang="de-DE" sz="1600" dirty="0"/>
-                <a:t>🇸🇮</a:t>
-              </a:r>
-              <a:endParaRPr lang="de-DE" sz="1050" dirty="0"/>
-            </a:p>
-          </p:txBody>
-        </p:sp>
-        <p:sp>
-          <p:nvSpPr>
-            <p:cNvPr id="148" name="Textfeld 147">
-              <a:extLst>
-                <a:ext uri="{FF2B5EF4-FFF2-40B4-BE49-F238E27FC236}">
-                  <a16:creationId xmlns:a16="http://schemas.microsoft.com/office/drawing/2014/main" id="{E7DA2480-C09A-61C7-2E9F-95EE7F44CA1B}"/>
-                </a:ext>
-              </a:extLst>
-            </p:cNvPr>
-            <p:cNvSpPr txBox="1"/>
-            <p:nvPr/>
-          </p:nvSpPr>
-          <p:spPr>
-            <a:xfrm>
-              <a:off x="13882915" y="8164283"/>
-              <a:ext cx="407907" cy="338554"/>
-            </a:xfrm>
-            <a:prstGeom prst="rect">
-              <a:avLst/>
-            </a:prstGeom>
-            <a:noFill/>
-          </p:spPr>
-          <p:txBody>
-            <a:bodyPr wrap="square" rtlCol="0">
-              <a:spAutoFit/>
-            </a:bodyPr>
-            <a:lstStyle/>
-            <a:p>
-              <a:r>
-                <a:rPr lang="de-DE" sz="1600" dirty="0"/>
-                <a:t>🇨🇿</a:t>
-              </a:r>
-              <a:endParaRPr lang="de-DE" sz="1050" dirty="0"/>
-            </a:p>
-          </p:txBody>
-        </p:sp>
-        <p:sp>
-          <p:nvSpPr>
-            <p:cNvPr id="149" name="Textfeld 148">
-              <a:extLst>
-                <a:ext uri="{FF2B5EF4-FFF2-40B4-BE49-F238E27FC236}">
-                  <a16:creationId xmlns:a16="http://schemas.microsoft.com/office/drawing/2014/main" id="{DFBF41DB-6F00-A6DE-1EE0-99D177CA7963}"/>
-                </a:ext>
-              </a:extLst>
-            </p:cNvPr>
-            <p:cNvSpPr txBox="1"/>
-            <p:nvPr/>
-          </p:nvSpPr>
-          <p:spPr>
-            <a:xfrm>
-              <a:off x="13882915" y="8440052"/>
-              <a:ext cx="407907" cy="338554"/>
-            </a:xfrm>
-            <a:prstGeom prst="rect">
-              <a:avLst/>
-            </a:prstGeom>
-            <a:noFill/>
-          </p:spPr>
-          <p:txBody>
-            <a:bodyPr wrap="square" rtlCol="0">
-              <a:spAutoFit/>
-            </a:bodyPr>
-            <a:lstStyle/>
-            <a:p>
-              <a:r>
-                <a:rPr lang="de-DE" sz="1600" dirty="0"/>
-                <a:t>🇬🇧</a:t>
-              </a:r>
-              <a:endParaRPr lang="de-DE" sz="1050" dirty="0"/>
-            </a:p>
-          </p:txBody>
-        </p:sp>
-        <p:sp>
-          <p:nvSpPr>
-            <p:cNvPr id="150" name="Textfeld 149">
-              <a:extLst>
-                <a:ext uri="{FF2B5EF4-FFF2-40B4-BE49-F238E27FC236}">
-                  <a16:creationId xmlns:a16="http://schemas.microsoft.com/office/drawing/2014/main" id="{DC7EB82A-908C-517E-80F8-7259C50EC77F}"/>
-                </a:ext>
-              </a:extLst>
-            </p:cNvPr>
-            <p:cNvSpPr txBox="1"/>
-            <p:nvPr/>
-          </p:nvSpPr>
-          <p:spPr>
-            <a:xfrm>
-              <a:off x="13882915" y="8715821"/>
-              <a:ext cx="407907" cy="338554"/>
-            </a:xfrm>
-            <a:prstGeom prst="rect">
-              <a:avLst/>
-            </a:prstGeom>
-            <a:noFill/>
-          </p:spPr>
-          <p:txBody>
-            <a:bodyPr wrap="square" rtlCol="0">
-              <a:spAutoFit/>
-            </a:bodyPr>
-            <a:lstStyle/>
-            <a:p>
-              <a:r>
-                <a:rPr lang="de-DE" sz="1600" dirty="0"/>
-                <a:t>🇮🇸</a:t>
-              </a:r>
-              <a:endParaRPr lang="de-DE" sz="1050" dirty="0"/>
-            </a:p>
-          </p:txBody>
-        </p:sp>
-        <p:sp>
-          <p:nvSpPr>
-            <p:cNvPr id="151" name="Textfeld 150">
-              <a:extLst>
-                <a:ext uri="{FF2B5EF4-FFF2-40B4-BE49-F238E27FC236}">
-                  <a16:creationId xmlns:a16="http://schemas.microsoft.com/office/drawing/2014/main" id="{825A1B1A-5580-85B5-3753-C62B68ADC97D}"/>
-                </a:ext>
-              </a:extLst>
-            </p:cNvPr>
-            <p:cNvSpPr txBox="1"/>
-            <p:nvPr/>
-          </p:nvSpPr>
-          <p:spPr>
-            <a:xfrm>
-              <a:off x="13882915" y="8984334"/>
-              <a:ext cx="407907" cy="338554"/>
-            </a:xfrm>
-            <a:prstGeom prst="rect">
-              <a:avLst/>
-            </a:prstGeom>
-            <a:noFill/>
-          </p:spPr>
-          <p:txBody>
-            <a:bodyPr wrap="square" rtlCol="0">
-              <a:spAutoFit/>
-            </a:bodyPr>
-            <a:lstStyle/>
-            <a:p>
-              <a:r>
-                <a:rPr lang="de-DE" sz="1600" dirty="0"/>
-                <a:t>🇭🇺</a:t>
-              </a:r>
-              <a:endParaRPr lang="de-DE" sz="1050" dirty="0"/>
-            </a:p>
-          </p:txBody>
-        </p:sp>
-        <p:sp>
-          <p:nvSpPr>
-            <p:cNvPr id="152" name="Textfeld 151">
-              <a:extLst>
-                <a:ext uri="{FF2B5EF4-FFF2-40B4-BE49-F238E27FC236}">
-                  <a16:creationId xmlns:a16="http://schemas.microsoft.com/office/drawing/2014/main" id="{B4F72F43-7C95-71AB-756F-8EC9995FA9CF}"/>
-                </a:ext>
-              </a:extLst>
-            </p:cNvPr>
-            <p:cNvSpPr txBox="1"/>
-            <p:nvPr/>
-          </p:nvSpPr>
-          <p:spPr>
-            <a:xfrm>
-              <a:off x="13882915" y="9267361"/>
-              <a:ext cx="407907" cy="338554"/>
-            </a:xfrm>
-            <a:prstGeom prst="rect">
-              <a:avLst/>
-            </a:prstGeom>
-            <a:noFill/>
-          </p:spPr>
-          <p:txBody>
-            <a:bodyPr wrap="square" rtlCol="0">
-              <a:spAutoFit/>
-            </a:bodyPr>
-            <a:lstStyle/>
-            <a:p>
-              <a:r>
-                <a:rPr lang="de-DE" sz="1600" dirty="0"/>
-                <a:t>🇫🇷</a:t>
-              </a:r>
-              <a:endParaRPr lang="de-DE" sz="1050" dirty="0"/>
-            </a:p>
-          </p:txBody>
-        </p:sp>
-        <p:sp>
-          <p:nvSpPr>
-            <p:cNvPr id="153" name="Textfeld 152">
-              <a:extLst>
-                <a:ext uri="{FF2B5EF4-FFF2-40B4-BE49-F238E27FC236}">
-                  <a16:creationId xmlns:a16="http://schemas.microsoft.com/office/drawing/2014/main" id="{035E5012-E789-4329-3D90-054F0F91BC75}"/>
-                </a:ext>
-              </a:extLst>
-            </p:cNvPr>
-            <p:cNvSpPr txBox="1"/>
-            <p:nvPr/>
-          </p:nvSpPr>
-          <p:spPr>
-            <a:xfrm>
-              <a:off x="13882915" y="9543131"/>
-              <a:ext cx="407907" cy="338554"/>
-            </a:xfrm>
-            <a:prstGeom prst="rect">
-              <a:avLst/>
-            </a:prstGeom>
-            <a:noFill/>
-          </p:spPr>
-          <p:txBody>
-            <a:bodyPr wrap="square" rtlCol="0">
-              <a:spAutoFit/>
-            </a:bodyPr>
-            <a:lstStyle/>
-            <a:p>
-              <a:r>
-                <a:rPr lang="de-DE" sz="1600" dirty="0"/>
-                <a:t>🇵🇱</a:t>
-              </a:r>
-              <a:endParaRPr lang="de-DE" sz="1050" dirty="0"/>
-            </a:p>
-          </p:txBody>
-        </p:sp>
-        <p:sp>
-          <p:nvSpPr>
-            <p:cNvPr id="154" name="Textfeld 153">
-              <a:extLst>
-                <a:ext uri="{FF2B5EF4-FFF2-40B4-BE49-F238E27FC236}">
-                  <a16:creationId xmlns:a16="http://schemas.microsoft.com/office/drawing/2014/main" id="{E0B8B658-5B08-12FA-04A8-9F4F81C89207}"/>
-                </a:ext>
-              </a:extLst>
-            </p:cNvPr>
-            <p:cNvSpPr txBox="1"/>
-            <p:nvPr/>
-          </p:nvSpPr>
-          <p:spPr>
-            <a:xfrm>
-              <a:off x="13882915" y="9818900"/>
-              <a:ext cx="407907" cy="338554"/>
-            </a:xfrm>
-            <a:prstGeom prst="rect">
-              <a:avLst/>
-            </a:prstGeom>
-            <a:noFill/>
-          </p:spPr>
-          <p:txBody>
-            <a:bodyPr wrap="square" rtlCol="0">
-              <a:spAutoFit/>
-            </a:bodyPr>
-            <a:lstStyle/>
-            <a:p>
-              <a:r>
-                <a:rPr lang="de-DE" sz="1600" dirty="0"/>
-                <a:t>🇵🇹</a:t>
-              </a:r>
-              <a:endParaRPr lang="de-DE" sz="1050" dirty="0"/>
-            </a:p>
-          </p:txBody>
-        </p:sp>
-      </p:grpSp>
       <p:pic>
         <p:nvPicPr>
           <p:cNvPr id="156" name="Grafik 155">
@@ -12655,7 +12207,7 @@
           <p:nvPr/>
         </p:nvPicPr>
         <p:blipFill>
-          <a:blip r:embed="rId11"/>
+          <a:blip r:embed="rId10"/>
           <a:stretch>
             <a:fillRect/>
           </a:stretch>
@@ -12924,7 +12476,7 @@
           <p:nvPr/>
         </p:nvPicPr>
         <p:blipFill>
-          <a:blip r:embed="rId12"/>
+          <a:blip r:embed="rId11"/>
           <a:stretch>
             <a:fillRect/>
           </a:stretch>
@@ -12954,7 +12506,7 @@
           <p:nvPr/>
         </p:nvPicPr>
         <p:blipFill>
-          <a:blip r:embed="rId13"/>
+          <a:blip r:embed="rId12"/>
           <a:stretch>
             <a:fillRect/>
           </a:stretch>
@@ -12984,7 +12536,7 @@
           <p:nvPr/>
         </p:nvPicPr>
         <p:blipFill>
-          <a:blip r:embed="rId14"/>
+          <a:blip r:embed="rId13"/>
           <a:stretch>
             <a:fillRect/>
           </a:stretch>
@@ -13071,6 +12623,37 @@
           </a:p>
         </p:txBody>
       </p:sp>
+      <p:pic>
+        <p:nvPicPr>
+          <p:cNvPr id="3" name="Grafik 2">
+            <a:extLst>
+              <a:ext uri="{FF2B5EF4-FFF2-40B4-BE49-F238E27FC236}">
+                <a16:creationId xmlns:a16="http://schemas.microsoft.com/office/drawing/2014/main" id="{A5583989-E8E8-F163-40FA-1C0073DDC5AB}"/>
+              </a:ext>
+            </a:extLst>
+          </p:cNvPr>
+          <p:cNvPicPr>
+            <a:picLocks noChangeAspect="1"/>
+          </p:cNvPicPr>
+          <p:nvPr/>
+        </p:nvPicPr>
+        <p:blipFill>
+          <a:blip r:embed="rId14"/>
+          <a:srcRect l="1894" r="3517"/>
+          <a:stretch>
+            <a:fillRect/>
+          </a:stretch>
+        </p:blipFill>
+        <p:spPr>
+          <a:xfrm>
+            <a:off x="14045856" y="6480914"/>
+            <a:ext cx="6554707" cy="3844990"/>
+          </a:xfrm>
+          <a:prstGeom prst="rect">
+            <a:avLst/>
+          </a:prstGeom>
+        </p:spPr>
+      </p:pic>
     </p:spTree>
     <p:extLst>
       <p:ext uri="{BB962C8B-B14F-4D97-AF65-F5344CB8AC3E}">

</xml_diff>

<commit_message>
small typos in poster
</commit_message>
<xml_diff>
--- a/Poster.pptx
+++ b/Poster.pptx
@@ -210,7 +210,7 @@
           <a:p>
             <a:fld id="{3496A8FA-5B42-674C-B20D-1B27C6B6ED8B}" type="datetimeFigureOut">
               <a:rPr lang="en-US" smtClean="0"/>
-              <a:t>4/22/26</a:t>
+              <a:t>4/23/26</a:t>
             </a:fld>
             <a:endParaRPr lang="en-US"/>
           </a:p>
@@ -375,7 +375,7 @@
           <a:p>
             <a:fld id="{3DFCF15A-2A27-7442-AB11-75F1A48A6AED}" type="datetimeFigureOut">
               <a:rPr lang="en-US" smtClean="0"/>
-              <a:t>4/22/26</a:t>
+              <a:t>4/23/26</a:t>
             </a:fld>
             <a:endParaRPr lang="en-US"/>
           </a:p>
@@ -2062,7 +2062,7 @@
           <a:p>
             <a:fld id="{C764DE79-268F-4C1A-8933-263129D2AF90}" type="datetimeFigureOut">
               <a:rPr lang="en-US" dirty="0"/>
-              <a:t>4/22/26</a:t>
+              <a:t>4/23/26</a:t>
             </a:fld>
             <a:endParaRPr lang="en-US" dirty="0"/>
           </a:p>
@@ -2319,7 +2319,7 @@
           <a:p>
             <a:fld id="{C764DE79-268F-4C1A-8933-263129D2AF90}" type="datetimeFigureOut">
               <a:rPr lang="en-US" dirty="0"/>
-              <a:t>4/22/26</a:t>
+              <a:t>4/23/26</a:t>
             </a:fld>
             <a:endParaRPr lang="en-US" dirty="0"/>
           </a:p>
@@ -2489,7 +2489,7 @@
           <a:p>
             <a:fld id="{C764DE79-268F-4C1A-8933-263129D2AF90}" type="datetimeFigureOut">
               <a:rPr lang="en-US" dirty="0"/>
-              <a:t>4/22/26</a:t>
+              <a:t>4/23/26</a:t>
             </a:fld>
             <a:endParaRPr lang="en-US" dirty="0"/>
           </a:p>
@@ -2669,7 +2669,7 @@
           <a:p>
             <a:fld id="{C764DE79-268F-4C1A-8933-263129D2AF90}" type="datetimeFigureOut">
               <a:rPr lang="en-US" dirty="0"/>
-              <a:t>4/22/26</a:t>
+              <a:t>4/23/26</a:t>
             </a:fld>
             <a:endParaRPr lang="en-US" dirty="0"/>
           </a:p>
@@ -4003,7 +4003,7 @@
           <a:p>
             <a:fld id="{C764DE79-268F-4C1A-8933-263129D2AF90}" type="datetimeFigureOut">
               <a:rPr lang="en-US" dirty="0"/>
-              <a:t>4/22/26</a:t>
+              <a:t>4/23/26</a:t>
             </a:fld>
             <a:endParaRPr lang="en-US" dirty="0"/>
           </a:p>
@@ -4173,7 +4173,7 @@
           <a:p>
             <a:fld id="{C764DE79-268F-4C1A-8933-263129D2AF90}" type="datetimeFigureOut">
               <a:rPr lang="en-US" dirty="0"/>
-              <a:t>4/22/26</a:t>
+              <a:t>4/23/26</a:t>
             </a:fld>
             <a:endParaRPr lang="en-US" dirty="0"/>
           </a:p>
@@ -4417,7 +4417,7 @@
           <a:p>
             <a:fld id="{C764DE79-268F-4C1A-8933-263129D2AF90}" type="datetimeFigureOut">
               <a:rPr lang="en-US" dirty="0"/>
-              <a:t>4/22/26</a:t>
+              <a:t>4/23/26</a:t>
             </a:fld>
             <a:endParaRPr lang="en-US" dirty="0"/>
           </a:p>
@@ -4649,7 +4649,7 @@
           <a:p>
             <a:fld id="{C764DE79-268F-4C1A-8933-263129D2AF90}" type="datetimeFigureOut">
               <a:rPr lang="en-US" dirty="0"/>
-              <a:t>4/22/26</a:t>
+              <a:t>4/23/26</a:t>
             </a:fld>
             <a:endParaRPr lang="en-US" dirty="0"/>
           </a:p>
@@ -5016,7 +5016,7 @@
           <a:p>
             <a:fld id="{C764DE79-268F-4C1A-8933-263129D2AF90}" type="datetimeFigureOut">
               <a:rPr lang="en-US" dirty="0"/>
-              <a:t>4/22/26</a:t>
+              <a:t>4/23/26</a:t>
             </a:fld>
             <a:endParaRPr lang="en-US" dirty="0"/>
           </a:p>
@@ -5134,7 +5134,7 @@
           <a:p>
             <a:fld id="{C764DE79-268F-4C1A-8933-263129D2AF90}" type="datetimeFigureOut">
               <a:rPr lang="en-US" dirty="0"/>
-              <a:t>4/22/26</a:t>
+              <a:t>4/23/26</a:t>
             </a:fld>
             <a:endParaRPr lang="en-US" dirty="0"/>
           </a:p>
@@ -5229,7 +5229,7 @@
           <a:p>
             <a:fld id="{C764DE79-268F-4C1A-8933-263129D2AF90}" type="datetimeFigureOut">
               <a:rPr lang="en-US" dirty="0"/>
-              <a:t>4/22/26</a:t>
+              <a:t>4/23/26</a:t>
             </a:fld>
             <a:endParaRPr lang="en-US" dirty="0"/>
           </a:p>
@@ -6253,7 +6253,7 @@
           <a:p>
             <a:fld id="{C764DE79-268F-4C1A-8933-263129D2AF90}" type="datetimeFigureOut">
               <a:rPr lang="en-US" dirty="0"/>
-              <a:t>4/22/26</a:t>
+              <a:t>4/23/26</a:t>
             </a:fld>
             <a:endParaRPr lang="en-US" dirty="0"/>
           </a:p>
@@ -7914,7 +7914,7 @@
         </p:nvCxnSpPr>
         <p:spPr bwMode="auto">
           <a:xfrm>
-            <a:off x="369889" y="15752003"/>
+            <a:off x="369889" y="15674183"/>
             <a:ext cx="20474391" cy="0"/>
           </a:xfrm>
           <a:prstGeom prst="line">
@@ -8250,7 +8250,7 @@
         <p:spPr>
           <a:xfrm>
             <a:off x="465652" y="24618997"/>
-            <a:ext cx="20667600" cy="4625497"/>
+            <a:ext cx="20430556" cy="4625497"/>
           </a:xfrm>
           <a:prstGeom prst="rect">
             <a:avLst/>
@@ -8596,7 +8596,7 @@
             </a:r>
           </a:p>
           <a:p>
-            <a:pPr indent="-653919">
+            <a:pPr marL="19050" indent="307975">
               <a:lnSpc>
                 <a:spcPts val="2988"/>
               </a:lnSpc>
@@ -8724,7 +8724,7 @@
         </p:nvSpPr>
         <p:spPr>
           <a:xfrm>
-            <a:off x="26813" y="27244640"/>
+            <a:off x="26813" y="27195212"/>
             <a:ext cx="21383230" cy="3309737"/>
           </a:xfrm>
           <a:prstGeom prst="rect">
@@ -9090,34 +9090,8 @@
                 <a:ea typeface="Roboto" panose="02000000000000000000" pitchFamily="2" charset="0"/>
                 <a:cs typeface="Roboto" panose="02000000000000000000" pitchFamily="2" charset="0"/>
               </a:rPr>
-              <a:t>Eurostat (2026a). At-risk-of-poverty rate by NUTS 2 region. ilc_li41 [Data set]. </a:t>
-            </a:r>
-            <a:r>
-              <a:rPr lang="en-US" sz="1400" dirty="0">
-                <a:solidFill>
-                  <a:schemeClr val="bg1"/>
-                </a:solidFill>
-                <a:latin typeface="Roboto" panose="02000000000000000000" pitchFamily="2" charset="0"/>
-                <a:ea typeface="Roboto" panose="02000000000000000000" pitchFamily="2" charset="0"/>
-                <a:cs typeface="Roboto" panose="02000000000000000000" pitchFamily="2" charset="0"/>
-                <a:hlinkClick r:id="rId4">
-                  <a:extLst>
-                    <a:ext uri="{A12FA001-AC4F-418D-AE19-62706E023703}">
-                      <ahyp:hlinkClr xmlns:ahyp="http://schemas.microsoft.com/office/drawing/2018/hyperlinkcolor" val="tx"/>
-                    </a:ext>
-                  </a:extLst>
-                </a:hlinkClick>
-              </a:rPr>
-              <a:t>https://doi.org/10.2908/ILC_LI41</a:t>
-            </a:r>
-            <a:endParaRPr lang="en-US" sz="1400" dirty="0">
-              <a:solidFill>
-                <a:schemeClr val="bg1"/>
-              </a:solidFill>
-              <a:latin typeface="Roboto" panose="02000000000000000000" pitchFamily="2" charset="0"/>
-              <a:ea typeface="Roboto" panose="02000000000000000000" pitchFamily="2" charset="0"/>
-              <a:cs typeface="Roboto" panose="02000000000000000000" pitchFamily="2" charset="0"/>
-            </a:endParaRPr>
+              <a:t>Eurostat (2026a). At-risk-of-poverty rate by NUTS 2 region. ilc_li41 [Data set]. https://doi.org/10.2908/ILC_LI41</a:t>
+            </a:r>
           </a:p>
           <a:p>
             <a:pPr lvl="0" defTabSz="914400" eaLnBrk="0" fontAlgn="base" hangingPunct="0">
@@ -9137,34 +9111,8 @@
                 <a:ea typeface="Roboto" panose="02000000000000000000" pitchFamily="2" charset="0"/>
                 <a:cs typeface="Roboto" panose="02000000000000000000" pitchFamily="2" charset="0"/>
               </a:rPr>
-              <a:t>Eurostat (2026b). Early leavers from education and training by NUTS 2 region. edat_lfse_16 [Data set]. </a:t>
-            </a:r>
-            <a:r>
-              <a:rPr lang="en-US" sz="1400" dirty="0">
-                <a:solidFill>
-                  <a:schemeClr val="bg1"/>
-                </a:solidFill>
-                <a:latin typeface="Roboto" panose="02000000000000000000" pitchFamily="2" charset="0"/>
-                <a:ea typeface="Roboto" panose="02000000000000000000" pitchFamily="2" charset="0"/>
-                <a:cs typeface="Roboto" panose="02000000000000000000" pitchFamily="2" charset="0"/>
-                <a:hlinkClick r:id="rId5">
-                  <a:extLst>
-                    <a:ext uri="{A12FA001-AC4F-418D-AE19-62706E023703}">
-                      <ahyp:hlinkClr xmlns:ahyp="http://schemas.microsoft.com/office/drawing/2018/hyperlinkcolor" val="tx"/>
-                    </a:ext>
-                  </a:extLst>
-                </a:hlinkClick>
-              </a:rPr>
-              <a:t>https://doi.org/10.2908/EDAT_LFSE_16</a:t>
-            </a:r>
-            <a:endParaRPr lang="en-US" sz="1400" dirty="0">
-              <a:solidFill>
-                <a:schemeClr val="bg1"/>
-              </a:solidFill>
-              <a:latin typeface="Roboto" panose="02000000000000000000" pitchFamily="2" charset="0"/>
-              <a:ea typeface="Roboto" panose="02000000000000000000" pitchFamily="2" charset="0"/>
-              <a:cs typeface="Roboto" panose="02000000000000000000" pitchFamily="2" charset="0"/>
-            </a:endParaRPr>
+              <a:t>Eurostat (2026b). Early leavers from education and training by NUTS 2 region. edat_lfse_16 [Data set]. https://doi.org/10.2908/EDAT_LFSE_16</a:t>
+            </a:r>
           </a:p>
           <a:p>
             <a:pPr lvl="0" defTabSz="914400" eaLnBrk="0" fontAlgn="base" hangingPunct="0">
@@ -9184,34 +9132,8 @@
                 <a:ea typeface="Roboto" panose="02000000000000000000" pitchFamily="2" charset="0"/>
                 <a:cs typeface="Roboto" panose="02000000000000000000" pitchFamily="2" charset="0"/>
               </a:rPr>
-              <a:t>Eurostat (2026c). Young persons neither in employment nor in education and training by NUTS 2 region. edat_lfse_22 [Data set]. </a:t>
-            </a:r>
-            <a:r>
-              <a:rPr lang="en-US" sz="1400" dirty="0">
-                <a:solidFill>
-                  <a:schemeClr val="bg1"/>
-                </a:solidFill>
-                <a:latin typeface="Roboto" panose="02000000000000000000" pitchFamily="2" charset="0"/>
-                <a:ea typeface="Roboto" panose="02000000000000000000" pitchFamily="2" charset="0"/>
-                <a:cs typeface="Roboto" panose="02000000000000000000" pitchFamily="2" charset="0"/>
-                <a:hlinkClick r:id="rId6">
-                  <a:extLst>
-                    <a:ext uri="{A12FA001-AC4F-418D-AE19-62706E023703}">
-                      <ahyp:hlinkClr xmlns:ahyp="http://schemas.microsoft.com/office/drawing/2018/hyperlinkcolor" val="tx"/>
-                    </a:ext>
-                  </a:extLst>
-                </a:hlinkClick>
-              </a:rPr>
-              <a:t>https://doi.org/10.2908/EDAT_LFSE_22</a:t>
-            </a:r>
-            <a:endParaRPr lang="en-US" sz="1400" dirty="0">
-              <a:solidFill>
-                <a:schemeClr val="bg1"/>
-              </a:solidFill>
-              <a:latin typeface="Roboto" panose="02000000000000000000" pitchFamily="2" charset="0"/>
-              <a:ea typeface="Roboto" panose="02000000000000000000" pitchFamily="2" charset="0"/>
-              <a:cs typeface="Roboto" panose="02000000000000000000" pitchFamily="2" charset="0"/>
-            </a:endParaRPr>
+              <a:t>Eurostat (2026c). Young persons neither in employment nor in education and training by NUTS 2 region. edat_lfse_22 [Data set]. https://doi.org/10.2908/EDAT_LFSE_22</a:t>
+            </a:r>
           </a:p>
           <a:p>
             <a:pPr lvl="0" defTabSz="914400" eaLnBrk="0" fontAlgn="base" hangingPunct="0">
@@ -9525,36 +9447,7 @@
                 <a:ea typeface="Roboto" panose="02000000000000000000" pitchFamily="2" charset="0"/>
                 <a:cs typeface="Roboto" panose="02000000000000000000" pitchFamily="2" charset="0"/>
               </a:rPr>
-              <a:t>	Equity in Education &amp; Society, 1(2), 279-296. </a:t>
-            </a:r>
-            <a:r>
-              <a:rPr lang="en-US" sz="1400" dirty="0">
-                <a:solidFill>
-                  <a:schemeClr val="bg1"/>
-                </a:solidFill>
-                <a:latin typeface="Roboto" panose="02000000000000000000" pitchFamily="2" charset="0"/>
-                <a:ea typeface="Roboto" panose="02000000000000000000" pitchFamily="2" charset="0"/>
-                <a:cs typeface="Roboto" panose="02000000000000000000" pitchFamily="2" charset="0"/>
-                <a:hlinkClick r:id="rId7">
-                  <a:extLst>
-                    <a:ext uri="{A12FA001-AC4F-418D-AE19-62706E023703}">
-                      <ahyp:hlinkClr xmlns:ahyp="http://schemas.microsoft.com/office/drawing/2018/hyperlinkcolor" val="tx"/>
-                    </a:ext>
-                  </a:extLst>
-                </a:hlinkClick>
-              </a:rPr>
-              <a:t>https://doi.org/10.1177/27526461221092429</a:t>
-            </a:r>
-            <a:r>
-              <a:rPr lang="en-US" sz="1400" dirty="0">
-                <a:solidFill>
-                  <a:schemeClr val="bg1"/>
-                </a:solidFill>
-                <a:latin typeface="Roboto" panose="02000000000000000000" pitchFamily="2" charset="0"/>
-                <a:ea typeface="Roboto" panose="02000000000000000000" pitchFamily="2" charset="0"/>
-                <a:cs typeface="Roboto" panose="02000000000000000000" pitchFamily="2" charset="0"/>
-              </a:rPr>
-              <a:t>	</a:t>
+              <a:t>	Equity in Education &amp; Society, 1(2), 279-296. https://doi.org/10.1177/27526461221092429	</a:t>
             </a:r>
             <a:r>
               <a:rPr lang="en-US" sz="1400" noProof="0" dirty="0">
@@ -9786,8 +9679,8 @@
         </p:nvSpPr>
         <p:spPr>
           <a:xfrm>
-            <a:off x="465652" y="16469249"/>
-            <a:ext cx="6828284" cy="7905369"/>
+            <a:off x="465652" y="16004886"/>
+            <a:ext cx="6828284" cy="8354210"/>
           </a:xfrm>
           <a:prstGeom prst="rect">
             <a:avLst/>
@@ -10017,7 +9910,7 @@
                 <a:latin typeface="Roboto" panose="02000000000000000000" pitchFamily="2" charset="0"/>
                 <a:ea typeface="Roboto" panose="02000000000000000000" pitchFamily="2" charset="0"/>
               </a:rPr>
-              <a:t>less fair</a:t>
+              <a:t>less fair – even after controlling for age</a:t>
             </a:r>
           </a:p>
           <a:p>
@@ -10103,41 +9996,6 @@
           <a:effectLst/>
         </p:spPr>
       </p:cxnSp>
-      <p:cxnSp>
-        <p:nvCxnSpPr>
-          <p:cNvPr id="9" name="Horizontal Section Divider" descr="Horizontal Divider">
-            <a:extLst>
-              <a:ext uri="{FF2B5EF4-FFF2-40B4-BE49-F238E27FC236}">
-                <a16:creationId xmlns:a16="http://schemas.microsoft.com/office/drawing/2014/main" id="{D4A93F4C-B2C6-E59C-C01D-35CFF29D6F2D}"/>
-              </a:ext>
-            </a:extLst>
-          </p:cNvPr>
-          <p:cNvCxnSpPr>
-            <a:cxnSpLocks/>
-          </p:cNvCxnSpPr>
-          <p:nvPr/>
-        </p:nvCxnSpPr>
-        <p:spPr bwMode="auto">
-          <a:xfrm>
-            <a:off x="18717884" y="27034308"/>
-            <a:ext cx="0" cy="2384734"/>
-          </a:xfrm>
-          <a:prstGeom prst="line">
-            <a:avLst/>
-          </a:prstGeom>
-          <a:noFill/>
-          <a:ln w="25400" cap="flat" cmpd="sng" algn="ctr">
-            <a:solidFill>
-              <a:schemeClr val="bg1"/>
-            </a:solidFill>
-            <a:prstDash val="dash"/>
-            <a:round/>
-            <a:headEnd type="none" w="med" len="med"/>
-            <a:tailEnd type="none" w="med" len="med"/>
-          </a:ln>
-          <a:effectLst/>
-        </p:spPr>
-      </p:cxnSp>
       <p:pic>
         <p:nvPicPr>
           <p:cNvPr id="32" name="Grafik 31">
@@ -10153,7 +10011,7 @@
           <p:nvPr/>
         </p:nvPicPr>
         <p:blipFill rotWithShape="1">
-          <a:blip r:embed="rId8"/>
+          <a:blip r:embed="rId4"/>
           <a:srcRect/>
           <a:stretch>
             <a:fillRect/>
@@ -10184,7 +10042,7 @@
           <p:nvPr>
             <p:extLst>
               <p:ext uri="{D42A27DB-BD31-4B8C-83A1-F6EECF244321}">
-                <p14:modId xmlns:p14="http://schemas.microsoft.com/office/powerpoint/2010/main" val="3789385460"/>
+                <p14:modId xmlns:p14="http://schemas.microsoft.com/office/powerpoint/2010/main" val="2260260255"/>
               </p:ext>
             </p:extLst>
           </p:nvPr>
@@ -10286,7 +10144,7 @@
                           <a:ea typeface="Roboto" panose="02000000000000000000" pitchFamily="2" charset="0"/>
                           <a:cs typeface="Roboto" panose="02000000000000000000" pitchFamily="2" charset="0"/>
                         </a:rPr>
-                        <a:t>Pillar / Dataset</a:t>
+                        <a:t>Pillar / Name</a:t>
                       </a:r>
                     </a:p>
                   </a:txBody>
@@ -11648,8 +11506,8 @@
         </p:nvCxnSpPr>
         <p:spPr bwMode="auto">
           <a:xfrm>
-            <a:off x="489800" y="24366114"/>
-            <a:ext cx="20643452" cy="0"/>
+            <a:off x="489800" y="24346659"/>
+            <a:ext cx="20289694" cy="0"/>
           </a:xfrm>
           <a:prstGeom prst="line">
             <a:avLst/>
@@ -11732,7 +11590,7 @@
         </p:nvSpPr>
         <p:spPr>
           <a:xfrm>
-            <a:off x="7733966" y="23518621"/>
+            <a:off x="7733966" y="23469193"/>
             <a:ext cx="13216878" cy="646331"/>
           </a:xfrm>
           <a:prstGeom prst="rect">
@@ -11752,7 +11610,7 @@
                 <a:ea typeface="Roboto" panose="02000000000000000000" pitchFamily="2" charset="0"/>
                 <a:cs typeface="Roboto" panose="02000000000000000000" pitchFamily="2" charset="0"/>
               </a:rPr>
-              <a:t>Figure 2: Regression coefficients of linear mixed model. Error bars indicate 95% confidence interval. </a:t>
+              <a:t>Figure 2: LMM coefficients of linear mixed model. Error bars indicate 95% confidence interval. </a:t>
             </a:r>
             <a:r>
               <a:rPr lang="en-US" sz="1800" noProof="0" dirty="0">
@@ -12011,7 +11869,7 @@
                 <a:latin typeface="Roboto" panose="02000000000000000000" pitchFamily="2" charset="0"/>
                 <a:ea typeface="Roboto" panose="02000000000000000000" pitchFamily="2" charset="0"/>
               </a:rPr>
-              <a:t> Policy-Makers should not just focus on aspects directly related to education, but especially on those </a:t>
+              <a:t> Policy-Makers should also focus on measures </a:t>
             </a:r>
             <a:r>
               <a:rPr lang="en-US" altLang="en-US" sz="2800" b="1" dirty="0">
@@ -12021,7 +11879,14 @@
                 <a:latin typeface="Roboto" panose="02000000000000000000" pitchFamily="2" charset="0"/>
                 <a:ea typeface="Roboto" panose="02000000000000000000" pitchFamily="2" charset="0"/>
               </a:rPr>
-              <a:t>related to the household</a:t>
+              <a:t>related to the household </a:t>
+            </a:r>
+            <a:r>
+              <a:rPr lang="en-US" altLang="en-US" sz="2800" dirty="0">
+                <a:latin typeface="Roboto" panose="02000000000000000000" pitchFamily="2" charset="0"/>
+                <a:ea typeface="Roboto" panose="02000000000000000000" pitchFamily="2" charset="0"/>
+              </a:rPr>
+              <a:t>(e.g., youth welfare and social work in families)</a:t>
             </a:r>
           </a:p>
           <a:p>
@@ -12088,7 +11953,7 @@
         </p:nvCxnSpPr>
         <p:spPr bwMode="auto">
           <a:xfrm>
-            <a:off x="520166" y="6292092"/>
+            <a:off x="520166" y="6311547"/>
             <a:ext cx="20324890" cy="0"/>
           </a:xfrm>
           <a:prstGeom prst="line">
@@ -12122,7 +11987,7 @@
           <p:nvPr/>
         </p:nvPicPr>
         <p:blipFill>
-          <a:blip r:embed="rId9"/>
+          <a:blip r:embed="rId5"/>
           <a:srcRect l="941" t="4784" r="1080" b="2406"/>
           <a:stretch>
             <a:fillRect/>
@@ -12172,7 +12037,7 @@
                 <a:ea typeface="Roboto" panose="02000000000000000000" pitchFamily="2" charset="0"/>
                 <a:cs typeface="Roboto" panose="02000000000000000000" pitchFamily="2" charset="0"/>
               </a:rPr>
-              <a:t>Figure 1: mean perceived fairness by gender (own calculations)</a:t>
+              <a:t>Figure 1: Mean perceived fairness by gender and country.</a:t>
             </a:r>
             <a:br>
               <a:rPr lang="en-US" sz="1800" noProof="0" dirty="0">
@@ -12187,8 +12052,21 @@
                 <a:ea typeface="Roboto" panose="02000000000000000000" pitchFamily="2" charset="0"/>
                 <a:cs typeface="Roboto" panose="02000000000000000000" pitchFamily="2" charset="0"/>
               </a:rPr>
-              <a:t>Note: x-axis adjusted for better visibility</a:t>
-            </a:r>
+              <a:t>Note: X-axis adjusted for better visibility </a:t>
+            </a:r>
+            <a:r>
+              <a:rPr lang="en-US" sz="1800" dirty="0">
+                <a:latin typeface="Roboto" panose="02000000000000000000" pitchFamily="2" charset="0"/>
+                <a:ea typeface="Roboto" panose="02000000000000000000" pitchFamily="2" charset="0"/>
+                <a:cs typeface="Roboto" panose="02000000000000000000" pitchFamily="2" charset="0"/>
+              </a:rPr>
+              <a:t>(own calculations)</a:t>
+            </a:r>
+            <a:endParaRPr lang="en-US" sz="1800" i="1" noProof="0" dirty="0">
+              <a:latin typeface="Roboto" panose="02000000000000000000" pitchFamily="2" charset="0"/>
+              <a:ea typeface="Roboto" panose="02000000000000000000" pitchFamily="2" charset="0"/>
+              <a:cs typeface="Roboto" panose="02000000000000000000" pitchFamily="2" charset="0"/>
+            </a:endParaRPr>
           </a:p>
         </p:txBody>
       </p:sp>
@@ -12207,14 +12085,14 @@
           <p:nvPr/>
         </p:nvPicPr>
         <p:blipFill>
-          <a:blip r:embed="rId10"/>
+          <a:blip r:embed="rId6"/>
           <a:stretch>
             <a:fillRect/>
           </a:stretch>
         </p:blipFill>
         <p:spPr>
           <a:xfrm>
-            <a:off x="7818846" y="16031304"/>
+            <a:off x="7818846" y="16056018"/>
             <a:ext cx="13025433" cy="7169108"/>
           </a:xfrm>
           <a:prstGeom prst="rect">
@@ -12476,7 +12354,7 @@
           <p:nvPr/>
         </p:nvPicPr>
         <p:blipFill>
-          <a:blip r:embed="rId11"/>
+          <a:blip r:embed="rId7"/>
           <a:stretch>
             <a:fillRect/>
           </a:stretch>
@@ -12506,7 +12384,7 @@
           <p:nvPr/>
         </p:nvPicPr>
         <p:blipFill>
-          <a:blip r:embed="rId12"/>
+          <a:blip r:embed="rId8"/>
           <a:stretch>
             <a:fillRect/>
           </a:stretch>
@@ -12536,14 +12414,14 @@
           <p:nvPr/>
         </p:nvPicPr>
         <p:blipFill>
-          <a:blip r:embed="rId13"/>
+          <a:blip r:embed="rId9"/>
           <a:stretch>
             <a:fillRect/>
           </a:stretch>
         </p:blipFill>
         <p:spPr>
           <a:xfrm>
-            <a:off x="19276210" y="27560838"/>
+            <a:off x="19276208" y="27560838"/>
             <a:ext cx="1620000" cy="1620000"/>
           </a:xfrm>
           <a:prstGeom prst="rect">
@@ -12638,7 +12516,7 @@
           <p:nvPr/>
         </p:nvPicPr>
         <p:blipFill>
-          <a:blip r:embed="rId14"/>
+          <a:blip r:embed="rId10"/>
           <a:srcRect l="1894" r="3517"/>
           <a:stretch>
             <a:fillRect/>
@@ -12654,6 +12532,76 @@
           </a:prstGeom>
         </p:spPr>
       </p:pic>
+      <p:cxnSp>
+        <p:nvCxnSpPr>
+          <p:cNvPr id="15" name="Horizontal Section Divider" descr="Horizontal Divider">
+            <a:extLst>
+              <a:ext uri="{FF2B5EF4-FFF2-40B4-BE49-F238E27FC236}">
+                <a16:creationId xmlns:a16="http://schemas.microsoft.com/office/drawing/2014/main" id="{37156DBA-3B56-F13A-3DE3-022ACE04F8F6}"/>
+              </a:ext>
+            </a:extLst>
+          </p:cNvPr>
+          <p:cNvCxnSpPr>
+            <a:cxnSpLocks/>
+          </p:cNvCxnSpPr>
+          <p:nvPr/>
+        </p:nvCxnSpPr>
+        <p:spPr bwMode="auto">
+          <a:xfrm>
+            <a:off x="14796883" y="27283550"/>
+            <a:ext cx="0" cy="2852739"/>
+          </a:xfrm>
+          <a:prstGeom prst="line">
+            <a:avLst/>
+          </a:prstGeom>
+          <a:noFill/>
+          <a:ln w="25400" cap="flat" cmpd="sng" algn="ctr">
+            <a:solidFill>
+              <a:schemeClr val="bg1"/>
+            </a:solidFill>
+            <a:prstDash val="dash"/>
+            <a:round/>
+            <a:headEnd type="none" w="med" len="med"/>
+            <a:tailEnd type="none" w="med" len="med"/>
+          </a:ln>
+          <a:effectLst/>
+        </p:spPr>
+      </p:cxnSp>
+      <p:cxnSp>
+        <p:nvCxnSpPr>
+          <p:cNvPr id="18" name="Horizontal Section Divider" descr="Horizontal Divider">
+            <a:extLst>
+              <a:ext uri="{FF2B5EF4-FFF2-40B4-BE49-F238E27FC236}">
+                <a16:creationId xmlns:a16="http://schemas.microsoft.com/office/drawing/2014/main" id="{2E787834-AA61-6113-6316-882746F4BF6A}"/>
+              </a:ext>
+            </a:extLst>
+          </p:cNvPr>
+          <p:cNvCxnSpPr>
+            <a:cxnSpLocks/>
+          </p:cNvCxnSpPr>
+          <p:nvPr/>
+        </p:nvCxnSpPr>
+        <p:spPr bwMode="auto">
+          <a:xfrm>
+            <a:off x="18717884" y="27034308"/>
+            <a:ext cx="0" cy="2384734"/>
+          </a:xfrm>
+          <a:prstGeom prst="line">
+            <a:avLst/>
+          </a:prstGeom>
+          <a:noFill/>
+          <a:ln w="25400" cap="flat" cmpd="sng" algn="ctr">
+            <a:solidFill>
+              <a:schemeClr val="bg1"/>
+            </a:solidFill>
+            <a:prstDash val="dash"/>
+            <a:round/>
+            <a:headEnd type="none" w="med" len="med"/>
+            <a:tailEnd type="none" w="med" len="med"/>
+          </a:ln>
+          <a:effectLst/>
+        </p:spPr>
+      </p:cxnSp>
     </p:spTree>
     <p:extLst>
       <p:ext uri="{BB962C8B-B14F-4D97-AF65-F5344CB8AC3E}">

</xml_diff>